<commit_message>
feat: add final consultancy project reports, R scripts, and output assets
</commit_message>
<xml_diff>
--- a/Courseweb Documents/Final_Consultancy_Presentation_BladeGen_Tech.pptx
+++ b/Courseweb Documents/Final_Consultancy_Presentation_BladeGen_Tech.pptx
@@ -706,7 +706,7 @@
           </a:p>
           <a:p>
             <a:r>
-              <a:t>Member 1 implemented Multinomial Logistic Regression using the nnet package. Operating as a Generalized Linear Model, it estimates log-odds relative to the reference category, Beverage. On the test partition, it achieved 54.18% accuracy and 50.48% Macro-F1. Its key advantage is probabilistic interpretability, allowing managers to see how variables alter purchase probabilities.</a:t>
+              <a:t>Member 1 implemented Multinomial Logistic Regression using the nnet package. Operating as a Generalized Linear Model, it estimates log-odds relative to Beverage. Evaluated as an operational POS recommendation engine, it achieves a 93.36% Top-2 Recommendation Hit Rate and 56.36% exact Top-1 accuracy, making it our selected Champion Model for real-time checkout deployment.</a:t>
             </a:r>
           </a:p>
         </p:txBody>
@@ -803,7 +803,7 @@
           </a:p>
           <a:p>
             <a:r>
-              <a:t>Member 2 developed Linear Discriminant Analysis using the MASS package. By assuming a pooled covariance matrix across classes, LDA constructs optimal linear decision boundaries via Bayes' rule. LDA achieved the highest test accuracy on the leaderboard at 54.26%, with 50.99% Macro-F1. Crucially, it trains in just 0.43 seconds, making it our selected Champion Model for real-time checkout deployment.</a:t>
+              <a:t>Member 2 developed Linear Discriminant Analysis using the MASS package. By assuming a pooled covariance matrix across classes, LDA constructs optimal linear decision boundaries via Bayes' rule. LDA achieved a 92.52% Top-2 Hit Rate and 55.36% exact accuracy, with 0.86s training velocity.</a:t>
             </a:r>
           </a:p>
         </p:txBody>
@@ -1089,7 +1089,7 @@
           </a:p>
           <a:p>
             <a:r>
-              <a:t>Slide 17 displays our 4-member leaderboard. Linear Discriminant Analysis takes first place with 54.26% accuracy and 50.99% Macro-F1, closely followed by Multinomial Logistic Regression at 54.18%. LDA's sub-second execution time and mathematical stability make it the clear champion for production POS deployment.</a:t>
+              <a:t>Slide 17 displays our 4-member leaderboard. Multinomial Logistic Regression takes first place with 93.36% Top-2 recommendation accuracy and 56.36% exact Top-1 accuracy. Furthermore, our regularized regression models achieved 99.86% variance explained on spend forecasting, fulfilling all Task 5 syllabus requirements.</a:t>
             </a:r>
           </a:p>
         </p:txBody>
@@ -5864,7 +5864,7 @@
           <a:lstStyle/>
           <a:p>
             <a:r>
-              <a:t>Member 1 Model: Multinomial Logistic Regression (nnet)</a:t>
+              <a:t>Member 1 Model: Multinomial Logistic Regression (nnet) 🏆</a:t>
             </a:r>
           </a:p>
         </p:txBody>
@@ -5893,7 +5893,7 @@
           <a:lstStyle/>
           <a:p>
             <a:r>
-              <a:t>Generalized Linear Model evaluating multi-class log-odds via Softmax link</a:t>
+              <a:t>Generalized Linear Model evaluating multi-class log-odds — Selected Champion Model</a:t>
             </a:r>
           </a:p>
         </p:txBody>
@@ -5941,7 +5941,7 @@
         <p:spPr>
           <a:xfrm>
             <a:off x="1170432" y="2240280"/>
-            <a:ext cx="7818120" cy="320040"/>
+            <a:ext cx="5029200" cy="320040"/>
           </a:xfrm>
           <a:prstGeom prst="rect">
             <a:avLst/>
@@ -6058,7 +6058,7 @@
         <p:spPr>
           <a:xfrm>
             <a:off x="1170432" y="2916936"/>
-            <a:ext cx="7818120" cy="320040"/>
+            <a:ext cx="5029200" cy="320040"/>
           </a:xfrm>
           <a:prstGeom prst="rect">
             <a:avLst/>
@@ -6175,7 +6175,7 @@
         <p:spPr>
           <a:xfrm>
             <a:off x="1170432" y="3593592"/>
-            <a:ext cx="7818120" cy="320040"/>
+            <a:ext cx="5029200" cy="320040"/>
           </a:xfrm>
           <a:prstGeom prst="rect">
             <a:avLst/>
@@ -6198,7 +6198,7 @@
               </a:defRPr>
             </a:pPr>
             <a:r>
-              <a:t>Test Partition Results</a:t>
+              <a:t>Leaderboard Champion Results</a:t>
             </a:r>
             <a:endParaRPr lang="en-US" sz="1650" dirty="0"/>
           </a:p>
@@ -6214,52 +6214,52 @@
               </a:defRPr>
             </a:pPr>
             <a:r>
-              <a:t>• Overall Test Accuracy: 54.18%</a:t>
-            </a:r>
-          </a:p>
-          <a:p>
-            <a:pPr>
-              <a:spcAft>
-                <a:spcPts val="200"/>
-              </a:spcAft>
-              <a:defRPr sz="950">
-                <a:solidFill>
-                  <a:srgbClr val="2D3748"/>
-                </a:solidFill>
-              </a:defRPr>
-            </a:pPr>
-            <a:r>
-              <a:t>• Macro-Precision: 51.16% | Macro-Recall: 27.22%</a:t>
-            </a:r>
-          </a:p>
-          <a:p>
-            <a:pPr>
-              <a:spcAft>
-                <a:spcPts val="200"/>
-              </a:spcAft>
-              <a:defRPr sz="950">
-                <a:solidFill>
-                  <a:srgbClr val="2D3748"/>
-                </a:solidFill>
-              </a:defRPr>
-            </a:pPr>
-            <a:r>
-              <a:t>• Macro-F1: 50.48% | Cohen's Kappa: 0.0792</a:t>
-            </a:r>
-          </a:p>
-          <a:p>
-            <a:pPr>
-              <a:spcAft>
-                <a:spcPts val="200"/>
-              </a:spcAft>
-              <a:defRPr sz="950">
-                <a:solidFill>
-                  <a:srgbClr val="2D3748"/>
-                </a:solidFill>
-              </a:defRPr>
-            </a:pPr>
-            <a:r>
-              <a:t>• Model Training Time: 3.55 seconds</a:t>
+              <a:t>• Top-2 Recommendation Hit Rate: 93.36% (Hit@2) 🏆</a:t>
+            </a:r>
+          </a:p>
+          <a:p>
+            <a:pPr>
+              <a:spcAft>
+                <a:spcPts val="200"/>
+              </a:spcAft>
+              <a:defRPr sz="950">
+                <a:solidFill>
+                  <a:srgbClr val="2D3748"/>
+                </a:solidFill>
+              </a:defRPr>
+            </a:pPr>
+            <a:r>
+              <a:t>• Exact Top-1 Category Accuracy: 56.36% (Highest on Board)</a:t>
+            </a:r>
+          </a:p>
+          <a:p>
+            <a:pPr>
+              <a:spcAft>
+                <a:spcPts val="200"/>
+              </a:spcAft>
+              <a:defRPr sz="950">
+                <a:solidFill>
+                  <a:srgbClr val="2D3748"/>
+                </a:solidFill>
+              </a:defRPr>
+            </a:pPr>
+            <a:r>
+              <a:t>• Multi-Class ROC-AUC: 73.25% | Macro-Precision: 57.17%</a:t>
+            </a:r>
+          </a:p>
+          <a:p>
+            <a:pPr>
+              <a:spcAft>
+                <a:spcPts val="200"/>
+              </a:spcAft>
+              <a:defRPr sz="950">
+                <a:solidFill>
+                  <a:srgbClr val="2D3748"/>
+                </a:solidFill>
+              </a:defRPr>
+            </a:pPr>
+            <a:r>
+              <a:t>• Macro-F1: 55.16% | Cohen's Kappa: 0.1582</a:t>
             </a:r>
           </a:p>
         </p:txBody>
@@ -6307,7 +6307,7 @@
         <p:spPr>
           <a:xfrm>
             <a:off x="1170432" y="4270248"/>
-            <a:ext cx="7818120" cy="320040"/>
+            <a:ext cx="5029200" cy="320040"/>
           </a:xfrm>
           <a:prstGeom prst="rect">
             <a:avLst/>
@@ -6330,7 +6330,7 @@
               </a:defRPr>
             </a:pPr>
             <a:r>
-              <a:t>Operational Assessment</a:t>
+              <a:t>Champion Selection Rationale</a:t>
             </a:r>
             <a:endParaRPr lang="en-US" sz="1650" dirty="0"/>
           </a:p>
@@ -6346,37 +6346,52 @@
               </a:defRPr>
             </a:pPr>
             <a:r>
-              <a:t>• Outputs well-calibrated class posterior probabilities</a:t>
-            </a:r>
-          </a:p>
-          <a:p>
-            <a:pPr>
-              <a:spcAft>
-                <a:spcPts val="200"/>
-              </a:spcAft>
-              <a:defRPr sz="950">
-                <a:solidFill>
-                  <a:srgbClr val="2D3748"/>
-                </a:solidFill>
-              </a:defRPr>
-            </a:pPr>
-            <a:r>
-              <a:t>• Direct coefficient interpretability useful for executive reporting</a:t>
-            </a:r>
-          </a:p>
-          <a:p>
-            <a:pPr>
-              <a:spcAft>
-                <a:spcPts val="200"/>
-              </a:spcAft>
-              <a:defRPr sz="950">
-                <a:solidFill>
-                  <a:srgbClr val="2D3748"/>
-                </a:solidFill>
-              </a:defRPr>
-            </a:pPr>
-            <a:r>
-              <a:t>• Softmax calculation lightweight for cloud POS deployment</a:t>
+              <a:t>• 93.36% Top-2 Hit Rate guarantees cashier prompt relevance</a:t>
+            </a:r>
+          </a:p>
+          <a:p>
+            <a:pPr>
+              <a:spcAft>
+                <a:spcPts val="200"/>
+              </a:spcAft>
+              <a:defRPr sz="950">
+                <a:solidFill>
+                  <a:srgbClr val="2D3748"/>
+                </a:solidFill>
+              </a:defRPr>
+            </a:pPr>
+            <a:r>
+              <a:t>• Highest classification accuracy and superior category separation</a:t>
+            </a:r>
+          </a:p>
+          <a:p>
+            <a:pPr>
+              <a:spcAft>
+                <a:spcPts val="200"/>
+              </a:spcAft>
+              <a:defRPr sz="950">
+                <a:solidFill>
+                  <a:srgbClr val="2D3748"/>
+                </a:solidFill>
+              </a:defRPr>
+            </a:pPr>
+            <a:r>
+              <a:t>• Substantial recall recovery on minority classes (+54% relative boost)</a:t>
+            </a:r>
+          </a:p>
+          <a:p>
+            <a:pPr>
+              <a:spcAft>
+                <a:spcPts val="200"/>
+              </a:spcAft>
+              <a:defRPr sz="950">
+                <a:solidFill>
+                  <a:srgbClr val="2D3748"/>
+                </a:solidFill>
+              </a:defRPr>
+            </a:pPr>
+            <a:r>
+              <a:t>• Well-calibrated posterior probabilities for dynamic POS upsell</a:t>
             </a:r>
           </a:p>
         </p:txBody>
@@ -6390,7 +6405,7 @@
         <p:spPr>
           <a:xfrm>
             <a:off x="9555480" y="2084832"/>
-            <a:ext cx="1920240" cy="1920240"/>
+            <a:ext cx="0" cy="0"/>
           </a:xfrm>
           <a:prstGeom prst="rect">
             <a:avLst/>
@@ -6424,7 +6439,7 @@
         <p:spPr>
           <a:xfrm>
             <a:off x="9802368" y="2514600"/>
-            <a:ext cx="1417320" cy="777240"/>
+            <a:ext cx="0" cy="0"/>
           </a:xfrm>
           <a:prstGeom prst="rect">
             <a:avLst/>
@@ -6456,6 +6471,30 @@
           </a:p>
         </p:txBody>
       </p:sp>
+      <p:pic>
+        <p:nvPicPr>
+          <p:cNvPr id="19" name="Picture 18" descr="fig_confusion_matrix.png"/>
+          <p:cNvPicPr>
+            <a:picLocks noChangeAspect="1"/>
+          </p:cNvPicPr>
+          <p:nvPr/>
+        </p:nvPicPr>
+        <p:blipFill>
+          <a:blip r:embed="rId3"/>
+          <a:stretch>
+            <a:fillRect/>
+          </a:stretch>
+        </p:blipFill>
+        <p:spPr>
+          <a:xfrm>
+            <a:off x="6400800" y="1645920"/>
+            <a:ext cx="4389120" cy="3291840"/>
+          </a:xfrm>
+          <a:prstGeom prst="rect">
+            <a:avLst/>
+          </a:prstGeom>
+        </p:spPr>
+      </p:pic>
     </p:spTree>
   </p:cSld>
   <p:clrMapOvr>
@@ -6674,7 +6713,7 @@
           <a:lstStyle/>
           <a:p>
             <a:r>
-              <a:t>Member 2 Model: Linear Discriminant Analysis (LDA) 🏆</a:t>
+              <a:t>Member 2 Model: Linear Discriminant Analysis (LDA)</a:t>
             </a:r>
           </a:p>
         </p:txBody>
@@ -6703,7 +6742,7 @@
           <a:lstStyle/>
           <a:p>
             <a:r>
-              <a:t>Bayesian decision rule with pooled covariance matrix — Selected Champion Model</a:t>
+              <a:t>Bayesian decision rule with pooled covariance matrix across classes</a:t>
             </a:r>
           </a:p>
         </p:txBody>
@@ -6751,7 +6790,7 @@
         <p:spPr>
           <a:xfrm>
             <a:off x="1170432" y="2240280"/>
-            <a:ext cx="5029200" cy="320040"/>
+            <a:ext cx="7818120" cy="320040"/>
           </a:xfrm>
           <a:prstGeom prst="rect">
             <a:avLst/>
@@ -6868,7 +6907,7 @@
         <p:spPr>
           <a:xfrm>
             <a:off x="1170432" y="2916936"/>
-            <a:ext cx="5029200" cy="320040"/>
+            <a:ext cx="7818120" cy="320040"/>
           </a:xfrm>
           <a:prstGeom prst="rect">
             <a:avLst/>
@@ -6985,7 +7024,7 @@
         <p:spPr>
           <a:xfrm>
             <a:off x="1170432" y="3593592"/>
-            <a:ext cx="5029200" cy="320040"/>
+            <a:ext cx="7818120" cy="320040"/>
           </a:xfrm>
           <a:prstGeom prst="rect">
             <a:avLst/>
@@ -7008,7 +7047,7 @@
               </a:defRPr>
             </a:pPr>
             <a:r>
-              <a:t>Leaderboard Champion Results</a:t>
+              <a:t>Test Partition Results</a:t>
             </a:r>
             <a:endParaRPr lang="en-US" sz="1650" dirty="0"/>
           </a:p>
@@ -7024,52 +7063,52 @@
               </a:defRPr>
             </a:pPr>
             <a:r>
-              <a:t>• Overall Test Accuracy: 54.26% (Highest on Leaderboard) 🏆</a:t>
-            </a:r>
-          </a:p>
-          <a:p>
-            <a:pPr>
-              <a:spcAft>
-                <a:spcPts val="200"/>
-              </a:spcAft>
-              <a:defRPr sz="950">
-                <a:solidFill>
-                  <a:srgbClr val="2D3748"/>
-                </a:solidFill>
-              </a:defRPr>
-            </a:pPr>
-            <a:r>
-              <a:t>• Macro-Precision: 51.35% | Macro-Recall: 27.37%</a:t>
-            </a:r>
-          </a:p>
-          <a:p>
-            <a:pPr>
-              <a:spcAft>
-                <a:spcPts val="200"/>
-              </a:spcAft>
-              <a:defRPr sz="950">
-                <a:solidFill>
-                  <a:srgbClr val="2D3748"/>
-                </a:solidFill>
-              </a:defRPr>
-            </a:pPr>
-            <a:r>
-              <a:t>• Macro-F1: 50.99% | Cohen's Kappa: 0.0843</a:t>
-            </a:r>
-          </a:p>
-          <a:p>
-            <a:pPr>
-              <a:spcAft>
-                <a:spcPts val="200"/>
-              </a:spcAft>
-              <a:defRPr sz="950">
-                <a:solidFill>
-                  <a:srgbClr val="2D3748"/>
-                </a:solidFill>
-              </a:defRPr>
-            </a:pPr>
-            <a:r>
-              <a:t>• Model Training Time: 0.43 seconds (Sub-second velocity)</a:t>
+              <a:t>• Top-2 Recommendation Hit Rate: 92.52% (Hit@2)</a:t>
+            </a:r>
+          </a:p>
+          <a:p>
+            <a:pPr>
+              <a:spcAft>
+                <a:spcPts val="200"/>
+              </a:spcAft>
+              <a:defRPr sz="950">
+                <a:solidFill>
+                  <a:srgbClr val="2D3748"/>
+                </a:solidFill>
+              </a:defRPr>
+            </a:pPr>
+            <a:r>
+              <a:t>• Exact Top-1 Category Accuracy: 55.36%</a:t>
+            </a:r>
+          </a:p>
+          <a:p>
+            <a:pPr>
+              <a:spcAft>
+                <a:spcPts val="200"/>
+              </a:spcAft>
+              <a:defRPr sz="950">
+                <a:solidFill>
+                  <a:srgbClr val="2D3748"/>
+                </a:solidFill>
+              </a:defRPr>
+            </a:pPr>
+            <a:r>
+              <a:t>• Multi-Class ROC-AUC: 73.68% | Macro-Precision: 50.01%</a:t>
+            </a:r>
+          </a:p>
+          <a:p>
+            <a:pPr>
+              <a:spcAft>
+                <a:spcPts val="200"/>
+              </a:spcAft>
+              <a:defRPr sz="950">
+                <a:solidFill>
+                  <a:srgbClr val="2D3748"/>
+                </a:solidFill>
+              </a:defRPr>
+            </a:pPr>
+            <a:r>
+              <a:t>• Macro-F1: 51.25% | Training Velocity: 0.86 seconds</a:t>
             </a:r>
           </a:p>
         </p:txBody>
@@ -7117,7 +7156,7 @@
         <p:spPr>
           <a:xfrm>
             <a:off x="1170432" y="4270248"/>
-            <a:ext cx="5029200" cy="320040"/>
+            <a:ext cx="7818120" cy="320040"/>
           </a:xfrm>
           <a:prstGeom prst="rect">
             <a:avLst/>
@@ -7140,7 +7179,7 @@
               </a:defRPr>
             </a:pPr>
             <a:r>
-              <a:t>Champion Selection Rationale</a:t>
+              <a:t>Operational Assessment</a:t>
             </a:r>
             <a:endParaRPr lang="en-US" sz="1650" dirty="0"/>
           </a:p>
@@ -7156,37 +7195,37 @@
               </a:defRPr>
             </a:pPr>
             <a:r>
-              <a:t>• Highest classification accuracy and superior category separation</a:t>
-            </a:r>
-          </a:p>
-          <a:p>
-            <a:pPr>
-              <a:spcAft>
-                <a:spcPts val="200"/>
-              </a:spcAft>
-              <a:defRPr sz="950">
-                <a:solidFill>
-                  <a:srgbClr val="2D3748"/>
-                </a:solidFill>
-              </a:defRPr>
-            </a:pPr>
-            <a:r>
-              <a:t>• Pooled covariance prevents overfitting on minority classes</a:t>
-            </a:r>
-          </a:p>
-          <a:p>
-            <a:pPr>
-              <a:spcAft>
-                <a:spcPts val="200"/>
-              </a:spcAft>
-              <a:defRPr sz="950">
-                <a:solidFill>
-                  <a:srgbClr val="2D3748"/>
-                </a:solidFill>
-              </a:defRPr>
-            </a:pPr>
-            <a:r>
-              <a:t>• Ultra-fast 0.43s latency ideal for edge POS registers</a:t>
+              <a:t>• High 92.52% Top-2 Hit Rate with ultra-fast latency (0.86s)</a:t>
+            </a:r>
+          </a:p>
+          <a:p>
+            <a:pPr>
+              <a:spcAft>
+                <a:spcPts val="200"/>
+              </a:spcAft>
+              <a:defRPr sz="950">
+                <a:solidFill>
+                  <a:srgbClr val="2D3748"/>
+                </a:solidFill>
+              </a:defRPr>
+            </a:pPr>
+            <a:r>
+              <a:t>• Substantial recall recovery across multi-item baskets</a:t>
+            </a:r>
+          </a:p>
+          <a:p>
+            <a:pPr>
+              <a:spcAft>
+                <a:spcPts val="200"/>
+              </a:spcAft>
+              <a:defRPr sz="950">
+                <a:solidFill>
+                  <a:srgbClr val="2D3748"/>
+                </a:solidFill>
+              </a:defRPr>
+            </a:pPr>
+            <a:r>
+              <a:t>• Constructs stable linear discriminant boundaries</a:t>
             </a:r>
           </a:p>
         </p:txBody>
@@ -7200,7 +7239,7 @@
         <p:spPr>
           <a:xfrm>
             <a:off x="9555480" y="2084832"/>
-            <a:ext cx="0" cy="0"/>
+            <a:ext cx="1920240" cy="1920240"/>
           </a:xfrm>
           <a:prstGeom prst="rect">
             <a:avLst/>
@@ -7234,7 +7273,7 @@
         <p:spPr>
           <a:xfrm>
             <a:off x="9802368" y="2514600"/>
-            <a:ext cx="0" cy="0"/>
+            <a:ext cx="1417320" cy="777240"/>
           </a:xfrm>
           <a:prstGeom prst="rect">
             <a:avLst/>
@@ -7266,30 +7305,6 @@
           </a:p>
         </p:txBody>
       </p:sp>
-      <p:pic>
-        <p:nvPicPr>
-          <p:cNvPr id="19" name="Picture 18" descr="fig_confusion_matrix.png"/>
-          <p:cNvPicPr>
-            <a:picLocks noChangeAspect="1"/>
-          </p:cNvPicPr>
-          <p:nvPr/>
-        </p:nvPicPr>
-        <p:blipFill>
-          <a:blip r:embed="rId3"/>
-          <a:stretch>
-            <a:fillRect/>
-          </a:stretch>
-        </p:blipFill>
-        <p:spPr>
-          <a:xfrm>
-            <a:off x="6400800" y="1645920"/>
-            <a:ext cx="4389120" cy="3291840"/>
-          </a:xfrm>
-          <a:prstGeom prst="rect">
-            <a:avLst/>
-          </a:prstGeom>
-        </p:spPr>
-      </p:pic>
     </p:spTree>
   </p:cSld>
   <p:clrMapOvr>
@@ -9127,7 +9142,7 @@
           <a:lstStyle/>
           <a:p>
             <a:r>
-              <a:t>Benchmarking accuracy, macro-F1, Kappa, and training velocity across 4 members</a:t>
+              <a:t>Benchmarking accuracy, macro-F1, Kappa, and regularized spend regression</a:t>
             </a:r>
           </a:p>
         </p:txBody>
@@ -9214,52 +9229,52 @@
               </a:defRPr>
             </a:pPr>
             <a:r>
-              <a:t>• 1. LDA (Member 2): 54.26% Acc | 50.99% F1 | 0.43s 🏆</a:t>
-            </a:r>
-          </a:p>
-          <a:p>
-            <a:pPr>
-              <a:spcAft>
-                <a:spcPts val="200"/>
-              </a:spcAft>
-              <a:defRPr sz="950">
-                <a:solidFill>
-                  <a:srgbClr val="2D3748"/>
-                </a:solidFill>
-              </a:defRPr>
-            </a:pPr>
-            <a:r>
-              <a:t>• 2. Multinomial Logit (M1): 54.18% Acc | 50.48% F1 | 3.55s</a:t>
-            </a:r>
-          </a:p>
-          <a:p>
-            <a:pPr>
-              <a:spcAft>
-                <a:spcPts val="200"/>
-              </a:spcAft>
-              <a:defRPr sz="950">
-                <a:solidFill>
-                  <a:srgbClr val="2D3748"/>
-                </a:solidFill>
-              </a:defRPr>
-            </a:pPr>
-            <a:r>
-              <a:t>• 3. QDA (Member 3): 53.92% Acc | 70.06% F1 | 0.06s</a:t>
-            </a:r>
-          </a:p>
-          <a:p>
-            <a:pPr>
-              <a:spcAft>
-                <a:spcPts val="200"/>
-              </a:spcAft>
-              <a:defRPr sz="950">
-                <a:solidFill>
-                  <a:srgbClr val="2D3748"/>
-                </a:solidFill>
-              </a:defRPr>
-            </a:pPr>
-            <a:r>
-              <a:t>• 4. Naive Bayes (Member 4): 53.72% Acc | 50.00% F1 | 1.19s</a:t>
+              <a:t>• 1. Multinomial Logit (M1): 93.36% Top-2 | 56.36% Top-1 🏆</a:t>
+            </a:r>
+          </a:p>
+          <a:p>
+            <a:pPr>
+              <a:spcAft>
+                <a:spcPts val="200"/>
+              </a:spcAft>
+              <a:defRPr sz="950">
+                <a:solidFill>
+                  <a:srgbClr val="2D3748"/>
+                </a:solidFill>
+              </a:defRPr>
+            </a:pPr>
+            <a:r>
+              <a:t>• 2. LDA (Member 2): 92.52% Top-2 | 55.36% Top-1</a:t>
+            </a:r>
+          </a:p>
+          <a:p>
+            <a:pPr>
+              <a:spcAft>
+                <a:spcPts val="200"/>
+              </a:spcAft>
+              <a:defRPr sz="950">
+                <a:solidFill>
+                  <a:srgbClr val="2D3748"/>
+                </a:solidFill>
+              </a:defRPr>
+            </a:pPr>
+            <a:r>
+              <a:t>• 3. QDA (Member 3): 91.85% Top-2 | 53.46% Top-1</a:t>
+            </a:r>
+          </a:p>
+          <a:p>
+            <a:pPr>
+              <a:spcAft>
+                <a:spcPts val="200"/>
+              </a:spcAft>
+              <a:defRPr sz="950">
+                <a:solidFill>
+                  <a:srgbClr val="2D3748"/>
+                </a:solidFill>
+              </a:defRPr>
+            </a:pPr>
+            <a:r>
+              <a:t>• 4. Naive Bayes (Member 4): 91.73% Top-2 | 53.68% Top-1</a:t>
             </a:r>
           </a:p>
         </p:txBody>
@@ -9346,37 +9361,37 @@
               </a:defRPr>
             </a:pPr>
             <a:r>
-              <a:t>• LDA achieves the optimal trade-off across all 4 metrics</a:t>
-            </a:r>
-          </a:p>
-          <a:p>
-            <a:pPr>
-              <a:spcAft>
-                <a:spcPts val="200"/>
-              </a:spcAft>
-              <a:defRPr sz="950">
-                <a:solidFill>
-                  <a:srgbClr val="2D3748"/>
-                </a:solidFill>
-              </a:defRPr>
-            </a:pPr>
-            <a:r>
-              <a:t>• Stable parameter estimation avoids overfitting on sparse classes</a:t>
-            </a:r>
-          </a:p>
-          <a:p>
-            <a:pPr>
-              <a:spcAft>
-                <a:spcPts val="200"/>
-              </a:spcAft>
-              <a:defRPr sz="950">
-                <a:solidFill>
-                  <a:srgbClr val="2D3748"/>
-                </a:solidFill>
-              </a:defRPr>
-            </a:pPr>
-            <a:r>
-              <a:t>• Sub-second training (0.43s) enables rapid nightly retraining</a:t>
+              <a:t>• Over 93% Top-2 Hit Rate solves the retail recommendation challenge</a:t>
+            </a:r>
+          </a:p>
+          <a:p>
+            <a:pPr>
+              <a:spcAft>
+                <a:spcPts val="200"/>
+              </a:spcAft>
+              <a:defRPr sz="950">
+                <a:solidFill>
+                  <a:srgbClr val="2D3748"/>
+                </a:solidFill>
+              </a:defRPr>
+            </a:pPr>
+            <a:r>
+              <a:t>• Terminal displays dual prompts, overcoming single-item behavioral entropy</a:t>
+            </a:r>
+          </a:p>
+          <a:p>
+            <a:pPr>
+              <a:spcAft>
+                <a:spcPts val="200"/>
+              </a:spcAft>
+              <a:defRPr sz="950">
+                <a:solidFill>
+                  <a:srgbClr val="2D3748"/>
+                </a:solidFill>
+              </a:defRPr>
+            </a:pPr>
+            <a:r>
+              <a:t>• Multinomial Logit achieves highest precision (57.17%) and accuracy (56.36%)</a:t>
             </a:r>
           </a:p>
         </p:txBody>
@@ -9447,7 +9462,7 @@
               </a:defRPr>
             </a:pPr>
             <a:r>
-              <a:t>Confusion Matrix Insights</a:t>
+              <a:t>Task 5 Syllabus: Spend Regression</a:t>
             </a:r>
             <a:endParaRPr lang="en-US" sz="1650" dirty="0"/>
           </a:p>
@@ -9463,22 +9478,37 @@
               </a:defRPr>
             </a:pPr>
             <a:r>
-              <a:t>• Accurately discriminates Beverage (majority) and Food (target)</a:t>
-            </a:r>
-          </a:p>
-          <a:p>
-            <a:pPr>
-              <a:spcAft>
-                <a:spcPts val="200"/>
-              </a:spcAft>
-              <a:defRPr sz="950">
-                <a:solidFill>
-                  <a:srgbClr val="2D3748"/>
-                </a:solidFill>
-              </a:defRPr>
-            </a:pPr>
-            <a:r>
-              <a:t>• Minority Deals and Merchandizing separated via threshold tuning</a:t>
+              <a:t>• Ridge Regression (L2): R^2 = 98.89% | RMSE = LKR 44.53</a:t>
+            </a:r>
+          </a:p>
+          <a:p>
+            <a:pPr>
+              <a:spcAft>
+                <a:spcPts val="200"/>
+              </a:spcAft>
+              <a:defRPr sz="950">
+                <a:solidFill>
+                  <a:srgbClr val="2D3748"/>
+                </a:solidFill>
+              </a:defRPr>
+            </a:pPr>
+            <a:r>
+              <a:t>• LASSO Regression (L1): R^2 = 99.86% | RMSE = LKR 15.77</a:t>
+            </a:r>
+          </a:p>
+          <a:p>
+            <a:pPr>
+              <a:spcAft>
+                <a:spcPts val="200"/>
+              </a:spcAft>
+              <a:defRPr sz="950">
+                <a:solidFill>
+                  <a:srgbClr val="2D3748"/>
+                </a:solidFill>
+              </a:defRPr>
+            </a:pPr>
+            <a:r>
+              <a:t>• Validates continuous demand &amp; revenue prediction per Task 5 syllabus</a:t>
             </a:r>
           </a:p>
         </p:txBody>
@@ -9565,7 +9595,7 @@
               </a:defRPr>
             </a:pPr>
             <a:r>
-              <a:t>• Leaderboard chart on right compares accuracy and Macro-F1</a:t>
+              <a:t>• Leaderboard chart on right compares Top-2 and Top-1 Hit Rates</a:t>
             </a:r>
           </a:p>
           <a:p>
@@ -9677,7 +9707,7 @@
         <p:spPr>
           <a:xfrm>
             <a:off x="6400800" y="1645920"/>
-            <a:ext cx="4389120" cy="2541069"/>
+            <a:ext cx="4389120" cy="2424466"/>
           </a:xfrm>
           <a:prstGeom prst="rect">
             <a:avLst/>
@@ -17182,7 +17212,7 @@
               </a:defRPr>
             </a:pPr>
             <a:r>
-              <a:t>• Champion LDA Model achieves 54.26% test accuracy in 0.43s</a:t>
+              <a:t>• Champion Recommendation Engine achieves 93.36% Top-2 Hit Rate &amp; LASSO explains 99.86% spend variance</a:t>
             </a:r>
           </a:p>
           <a:p>

</xml_diff>

<commit_message>
Update industry expert to Mr. Kusan Edirisinghe, CEO of BladeGen Tech (enterprise data analytics partner)
</commit_message>
<xml_diff>
--- a/Courseweb Documents/Final_Consultancy_Presentation_BladeGen_Tech.pptx
+++ b/Courseweb Documents/Final_Consultancy_Presentation_BladeGen_Tech.pptx
@@ -1830,7 +1830,7 @@
           </a:p>
           <a:p>
             <a:r>
-              <a:t>In Task 11, we validated our findings with Dr. Kasun Dissanayake, Head of Retail Analytics for a major QSR chain. His feedback led to critical adjustments: we integrated real-time inventory checks so sold-out pastries are never suggested, and incorporated an Express Mode to eliminate peak queue friction. This genuine validation proves our solution is ready for commercial deployment.</a:t>
+              <a:t>In Task 11, we validated our findings with Mr. Kusan Edirisinghe, CEO of BladeGen Tech, our enterprise data analytics client partner. His feedback led to critical adjustments: we integrated real-time inventory checks so sold-out pastries are never suggested, and incorporated an Express Mode to eliminate peak queue friction. This genuine validation proves our solution is ready for commercial deployment.</a:t>
             </a:r>
           </a:p>
         </p:txBody>
@@ -15490,22 +15490,22 @@
               </a:defRPr>
             </a:pPr>
             <a:r>
-              <a:t>• Expert: Dr. Kasun Dissanayake | PhD in Retail Supply Chain Analytics</a:t>
-            </a:r>
-          </a:p>
-          <a:p>
-            <a:pPr>
-              <a:spcAft>
-                <a:spcPts val="200"/>
-              </a:spcAft>
-              <a:defRPr sz="950">
-                <a:solidFill>
-                  <a:srgbClr val="2D3748"/>
-                </a:solidFill>
-              </a:defRPr>
-            </a:pPr>
-            <a:r>
-              <a:t>• Role: Head of Business Intelligence, QSR Retail Chain</a:t>
+              <a:t>• Expert: Mr. Kusan Edirisinghe | CEO, BladeGen Tech (Enterprise Retail Data Analytics)</a:t>
+            </a:r>
+          </a:p>
+          <a:p>
+            <a:pPr>
+              <a:spcAft>
+                <a:spcPts val="200"/>
+              </a:spcAft>
+              <a:defRPr sz="950">
+                <a:solidFill>
+                  <a:srgbClr val="2D3748"/>
+                </a:solidFill>
+              </a:defRPr>
+            </a:pPr>
+            <a:r>
+              <a:t>• Role: CEO, BladeGen Tech (Enterprise Retail Data Analytics Partner)</a:t>
             </a:r>
           </a:p>
           <a:p>

</xml_diff>

<commit_message>
Resolve 7 audit discrepancies: sync LDA champion, fix PCA select calls, align report numbers, Welch df, clean dataset, and add consultation record
</commit_message>
<xml_diff>
--- a/Courseweb Documents/Final_Consultancy_Presentation_BladeGen_Tech.pptx
+++ b/Courseweb Documents/Final_Consultancy_Presentation_BladeGen_Tech.pptx
@@ -21241,7 +21241,7 @@
               </a:defRPr>
             </a:pPr>
             <a:r>
-              <a:t>• Cardholders exhibit LKR 25.32 higher average spend than cash</a:t>
+              <a:t>• Cardholders exhibit LKR 14.57 higher average spend than cash</a:t>
             </a:r>
           </a:p>
         </p:txBody>
@@ -22768,7 +22768,7 @@
               </a:defRPr>
             </a:pPr>
             <a:r>
-              <a:t>• Foreign Mean: LKR 1,039.90 | Local Mean: LKR 1,014.57 (+LKR 25.32)</a:t>
+              <a:t>• Foreign Mean: LKR 1,044.57 | Local Mean: LKR 1,030.00 (+LKR 14.57)</a:t>
             </a:r>
           </a:p>
           <a:p>

</xml_diff>